<commit_message>
Update Winter Term Presentation.pptx
</commit_message>
<xml_diff>
--- a/Current Presentation/Winter Term Presentation.pptx
+++ b/Current Presentation/Winter Term Presentation.pptx
@@ -118,6 +118,14 @@
 </p:presentation>
 </file>
 
+<file path=ppt/revisionInfo.xml><?xml version="1.0" encoding="utf-8"?>
+<p1510:revInfo xmlns:a="http://schemas.openxmlformats.org/drawingml/2006/main" xmlns:r="http://schemas.openxmlformats.org/officeDocument/2006/relationships" xmlns:p1510="http://schemas.microsoft.com/office/powerpoint/2015/10/main">
+  <p1510:revLst>
+    <p1510:client id="{A45A7E3B-7003-CEEA-491B-F8CDF23E9831}" v="268" dt="2026-03-25T15:21:03.775"/>
+  </p1510:revLst>
+</p1510:revInfo>
+</file>
+
 <file path=ppt/notesMasters/notesMaster1.xml><?xml version="1.0" encoding="utf-8"?>
 <p:notesMaster xmlns:a="http://schemas.openxmlformats.org/drawingml/2006/main" xmlns:r="http://schemas.openxmlformats.org/officeDocument/2006/relationships" xmlns:p="http://schemas.openxmlformats.org/presentationml/2006/main">
   <p:cSld>
@@ -200,7 +208,7 @@
           <a:p>
             <a:fld id="{9B30722A-02D2-41F8-B026-FA0401D54278}" type="datetimeFigureOut">
               <a:rPr lang="en-US" smtClean="0"/>
-              <a:t>3/22/2026</a:t>
+              <a:t>3/25/2026</a:t>
             </a:fld>
             <a:endParaRPr lang="en-US"/>
           </a:p>
@@ -889,7 +897,7 @@
           <a:p>
             <a:fld id="{F50EBB9A-EC33-4563-8904-8C39D38448B7}" type="datetimeFigureOut">
               <a:rPr lang="en-US" smtClean="0"/>
-              <a:t>3/21/2026</a:t>
+              <a:t>3/25/2026</a:t>
             </a:fld>
             <a:endParaRPr lang="en-US"/>
           </a:p>
@@ -1977,7 +1985,7 @@
           <a:p>
             <a:fld id="{F50EBB9A-EC33-4563-8904-8C39D38448B7}" type="datetimeFigureOut">
               <a:rPr lang="en-US" smtClean="0"/>
-              <a:t>3/21/2026</a:t>
+              <a:t>3/25/2026</a:t>
             </a:fld>
             <a:endParaRPr lang="en-US"/>
           </a:p>
@@ -2957,7 +2965,7 @@
           <a:p>
             <a:fld id="{F50EBB9A-EC33-4563-8904-8C39D38448B7}" type="datetimeFigureOut">
               <a:rPr lang="en-US" smtClean="0"/>
-              <a:t>3/21/2026</a:t>
+              <a:t>3/25/2026</a:t>
             </a:fld>
             <a:endParaRPr lang="en-US"/>
           </a:p>
@@ -4091,7 +4099,7 @@
           <a:p>
             <a:fld id="{F50EBB9A-EC33-4563-8904-8C39D38448B7}" type="datetimeFigureOut">
               <a:rPr lang="en-US" smtClean="0"/>
-              <a:t>3/21/2026</a:t>
+              <a:t>3/25/2026</a:t>
             </a:fld>
             <a:endParaRPr lang="en-US"/>
           </a:p>
@@ -5124,7 +5132,7 @@
           <a:p>
             <a:fld id="{F50EBB9A-EC33-4563-8904-8C39D38448B7}" type="datetimeFigureOut">
               <a:rPr lang="en-US" smtClean="0"/>
-              <a:t>3/21/2026</a:t>
+              <a:t>3/25/2026</a:t>
             </a:fld>
             <a:endParaRPr lang="en-US"/>
           </a:p>
@@ -5784,7 +5792,7 @@
           <a:p>
             <a:fld id="{F50EBB9A-EC33-4563-8904-8C39D38448B7}" type="datetimeFigureOut">
               <a:rPr lang="en-US" smtClean="0"/>
-              <a:t>3/21/2026</a:t>
+              <a:t>3/25/2026</a:t>
             </a:fld>
             <a:endParaRPr lang="en-US"/>
           </a:p>
@@ -6645,7 +6653,7 @@
           <a:p>
             <a:fld id="{F50EBB9A-EC33-4563-8904-8C39D38448B7}" type="datetimeFigureOut">
               <a:rPr lang="en-US" smtClean="0"/>
-              <a:t>3/21/2026</a:t>
+              <a:t>3/25/2026</a:t>
             </a:fld>
             <a:endParaRPr lang="en-US"/>
           </a:p>
@@ -6835,7 +6843,7 @@
           <a:p>
             <a:fld id="{F50EBB9A-EC33-4563-8904-8C39D38448B7}" type="datetimeFigureOut">
               <a:rPr lang="en-US" smtClean="0"/>
-              <a:t>3/21/2026</a:t>
+              <a:t>3/25/2026</a:t>
             </a:fld>
             <a:endParaRPr lang="en-US"/>
           </a:p>
@@ -7807,7 +7815,7 @@
           <a:p>
             <a:fld id="{F50EBB9A-EC33-4563-8904-8C39D38448B7}" type="datetimeFigureOut">
               <a:rPr lang="en-US" smtClean="0"/>
-              <a:t>3/21/2026</a:t>
+              <a:t>3/25/2026</a:t>
             </a:fld>
             <a:endParaRPr lang="en-US"/>
           </a:p>
@@ -8018,7 +8026,7 @@
           <a:p>
             <a:fld id="{F50EBB9A-EC33-4563-8904-8C39D38448B7}" type="datetimeFigureOut">
               <a:rPr lang="en-US" smtClean="0"/>
-              <a:t>3/21/2026</a:t>
+              <a:t>3/25/2026</a:t>
             </a:fld>
             <a:endParaRPr lang="en-US"/>
           </a:p>
@@ -9052,7 +9060,7 @@
           <a:p>
             <a:fld id="{F50EBB9A-EC33-4563-8904-8C39D38448B7}" type="datetimeFigureOut">
               <a:rPr lang="en-US" smtClean="0"/>
-              <a:t>3/21/2026</a:t>
+              <a:t>3/25/2026</a:t>
             </a:fld>
             <a:endParaRPr lang="en-US"/>
           </a:p>
@@ -9324,7 +9332,7 @@
           <a:p>
             <a:fld id="{F50EBB9A-EC33-4563-8904-8C39D38448B7}" type="datetimeFigureOut">
               <a:rPr lang="en-US" smtClean="0"/>
-              <a:t>3/21/2026</a:t>
+              <a:t>3/25/2026</a:t>
             </a:fld>
             <a:endParaRPr lang="en-US"/>
           </a:p>
@@ -9734,7 +9742,7 @@
           <a:p>
             <a:fld id="{F50EBB9A-EC33-4563-8904-8C39D38448B7}" type="datetimeFigureOut">
               <a:rPr lang="en-US" smtClean="0"/>
-              <a:t>3/21/2026</a:t>
+              <a:t>3/25/2026</a:t>
             </a:fld>
             <a:endParaRPr lang="en-US"/>
           </a:p>
@@ -9861,7 +9869,7 @@
           <a:p>
             <a:fld id="{F50EBB9A-EC33-4563-8904-8C39D38448B7}" type="datetimeFigureOut">
               <a:rPr lang="en-US" smtClean="0"/>
-              <a:t>3/21/2026</a:t>
+              <a:t>3/25/2026</a:t>
             </a:fld>
             <a:endParaRPr lang="en-US"/>
           </a:p>
@@ -9956,7 +9964,7 @@
           <a:p>
             <a:fld id="{F50EBB9A-EC33-4563-8904-8C39D38448B7}" type="datetimeFigureOut">
               <a:rPr lang="en-US" smtClean="0"/>
-              <a:t>3/21/2026</a:t>
+              <a:t>3/25/2026</a:t>
             </a:fld>
             <a:endParaRPr lang="en-US"/>
           </a:p>
@@ -11037,7 +11045,7 @@
           <a:p>
             <a:fld id="{F50EBB9A-EC33-4563-8904-8C39D38448B7}" type="datetimeFigureOut">
               <a:rPr lang="en-US" smtClean="0"/>
-              <a:t>3/21/2026</a:t>
+              <a:t>3/25/2026</a:t>
             </a:fld>
             <a:endParaRPr lang="en-US"/>
           </a:p>
@@ -12145,7 +12153,7 @@
           <a:p>
             <a:fld id="{F50EBB9A-EC33-4563-8904-8C39D38448B7}" type="datetimeFigureOut">
               <a:rPr lang="en-US" smtClean="0"/>
-              <a:t>3/21/2026</a:t>
+              <a:t>3/25/2026</a:t>
             </a:fld>
             <a:endParaRPr lang="en-US"/>
           </a:p>
@@ -13142,7 +13150,7 @@
           <a:p>
             <a:fld id="{F50EBB9A-EC33-4563-8904-8C39D38448B7}" type="datetimeFigureOut">
               <a:rPr lang="en-US" smtClean="0"/>
-              <a:t>3/21/2026</a:t>
+              <a:t>3/25/2026</a:t>
             </a:fld>
             <a:endParaRPr lang="en-US"/>
           </a:p>
@@ -13893,13 +13901,13 @@
   <p:clrMapOvr>
     <a:masterClrMapping/>
   </p:clrMapOvr>
-  <mc:AlternateContent xmlns:mc="http://schemas.openxmlformats.org/markup-compatibility/2006">
-    <mc:Choice xmlns:p15="http://schemas.microsoft.com/office/powerpoint/2012/main" Requires="p15">
+  <mc:AlternateContent xmlns:mc="http://schemas.openxmlformats.org/markup-compatibility/2006" xmlns:p15="http://schemas.microsoft.com/office/powerpoint/2012/main">
+    <mc:Choice Requires="p15">
       <p:transition xmlns:p14="http://schemas.microsoft.com/office/powerpoint/2010/main" spd="slow" p14:dur="6000">
         <p15:prstTrans prst="curtains"/>
       </p:transition>
     </mc:Choice>
-    <mc:Fallback>
+    <mc:Fallback xmlns="">
       <p:transition spd="slow">
         <p:fade/>
       </p:transition>
@@ -14635,13 +14643,12 @@
         </p:nvSpPr>
         <p:spPr/>
         <p:txBody>
-          <a:bodyPr/>
+          <a:bodyPr vert="horz" lIns="91440" tIns="45720" rIns="91440" bIns="45720" rtlCol="0" anchor="t">
+            <a:normAutofit/>
+          </a:bodyPr>
           <a:lstStyle/>
           <a:p>
-            <a:r>
-              <a:rPr lang="en-US" dirty="0"/>
-              <a:t>In independence I, well, honestly, am not 100% positive what I got out of it. But, I, uh… </a:t>
-            </a:r>
+            <a:endParaRPr lang="en-US" dirty="0"/>
           </a:p>
         </p:txBody>
       </p:sp>
@@ -14655,13 +14662,13 @@
   <p:clrMapOvr>
     <a:masterClrMapping/>
   </p:clrMapOvr>
-  <mc:AlternateContent xmlns:mc="http://schemas.openxmlformats.org/markup-compatibility/2006">
-    <mc:Choice xmlns:p15="http://schemas.microsoft.com/office/powerpoint/2012/main" Requires="p15">
+  <mc:AlternateContent xmlns:mc="http://schemas.openxmlformats.org/markup-compatibility/2006" xmlns:p15="http://schemas.microsoft.com/office/powerpoint/2012/main">
+    <mc:Choice Requires="p15">
       <p:transition xmlns:p14="http://schemas.microsoft.com/office/powerpoint/2010/main" spd="slow" p14:dur="2000">
         <p15:prstTrans prst="fallOver"/>
       </p:transition>
     </mc:Choice>
-    <mc:Fallback>
+    <mc:Fallback xmlns="">
       <p:transition spd="slow">
         <p:fade/>
       </p:transition>
@@ -14761,6 +14768,278 @@
           </a:p>
         </p:txBody>
       </p:sp>
+      <p:pic>
+        <p:nvPicPr>
+          <p:cNvPr id="4" name="Picture 3" descr="A screenshot of a computer program&#10;&#10;AI-generated content may be incorrect.">
+            <a:extLst>
+              <a:ext uri="{FF2B5EF4-FFF2-40B4-BE49-F238E27FC236}">
+                <a16:creationId xmlns:a16="http://schemas.microsoft.com/office/drawing/2014/main" id="{1CBA9DED-7D9A-AC9C-8F88-DAB397F71DFD}"/>
+              </a:ext>
+            </a:extLst>
+          </p:cNvPr>
+          <p:cNvPicPr>
+            <a:picLocks noChangeAspect="1"/>
+          </p:cNvPicPr>
+          <p:nvPr/>
+        </p:nvPicPr>
+        <p:blipFill>
+          <a:blip r:embed="rId2"/>
+          <a:stretch>
+            <a:fillRect/>
+          </a:stretch>
+        </p:blipFill>
+        <p:spPr>
+          <a:xfrm>
+            <a:off x="8965557" y="1878338"/>
+            <a:ext cx="3229447" cy="1960599"/>
+          </a:xfrm>
+          <a:prstGeom prst="rect">
+            <a:avLst/>
+          </a:prstGeom>
+        </p:spPr>
+      </p:pic>
+      <p:pic>
+        <p:nvPicPr>
+          <p:cNvPr id="5" name="Picture 4" descr="A screenshot of a computer&#10;&#10;AI-generated content may be incorrect.">
+            <a:extLst>
+              <a:ext uri="{FF2B5EF4-FFF2-40B4-BE49-F238E27FC236}">
+                <a16:creationId xmlns:a16="http://schemas.microsoft.com/office/drawing/2014/main" id="{B0575A5C-872B-8A8A-D9C1-8EDA4DF92084}"/>
+              </a:ext>
+            </a:extLst>
+          </p:cNvPr>
+          <p:cNvPicPr>
+            <a:picLocks noChangeAspect="1"/>
+          </p:cNvPicPr>
+          <p:nvPr/>
+        </p:nvPicPr>
+        <p:blipFill>
+          <a:blip r:embed="rId3"/>
+          <a:stretch>
+            <a:fillRect/>
+          </a:stretch>
+        </p:blipFill>
+        <p:spPr>
+          <a:xfrm>
+            <a:off x="7308220" y="1468617"/>
+            <a:ext cx="1371674" cy="817327"/>
+          </a:xfrm>
+          <a:prstGeom prst="rect">
+            <a:avLst/>
+          </a:prstGeom>
+        </p:spPr>
+      </p:pic>
+      <p:pic>
+        <p:nvPicPr>
+          <p:cNvPr id="6" name="Picture 5" descr="A screenshot of a computer&#10;&#10;AI-generated content may be incorrect.">
+            <a:extLst>
+              <a:ext uri="{FF2B5EF4-FFF2-40B4-BE49-F238E27FC236}">
+                <a16:creationId xmlns:a16="http://schemas.microsoft.com/office/drawing/2014/main" id="{EF61D584-DDA5-C1FE-6A82-D8EEAE314235}"/>
+              </a:ext>
+            </a:extLst>
+          </p:cNvPr>
+          <p:cNvPicPr>
+            <a:picLocks noChangeAspect="1"/>
+          </p:cNvPicPr>
+          <p:nvPr/>
+        </p:nvPicPr>
+        <p:blipFill>
+          <a:blip r:embed="rId4"/>
+          <a:stretch>
+            <a:fillRect/>
+          </a:stretch>
+        </p:blipFill>
+        <p:spPr>
+          <a:xfrm>
+            <a:off x="1363522" y="5534086"/>
+            <a:ext cx="2076450" cy="1133475"/>
+          </a:xfrm>
+          <a:prstGeom prst="rect">
+            <a:avLst/>
+          </a:prstGeom>
+        </p:spPr>
+      </p:pic>
+      <p:pic>
+        <p:nvPicPr>
+          <p:cNvPr id="7" name="Picture 6" descr="A screenshot of a computer&#10;&#10;AI-generated content may be incorrect.">
+            <a:extLst>
+              <a:ext uri="{FF2B5EF4-FFF2-40B4-BE49-F238E27FC236}">
+                <a16:creationId xmlns:a16="http://schemas.microsoft.com/office/drawing/2014/main" id="{1C3BA979-7AD0-ED69-E5F2-5650A788F93E}"/>
+              </a:ext>
+            </a:extLst>
+          </p:cNvPr>
+          <p:cNvPicPr>
+            <a:picLocks noChangeAspect="1"/>
+          </p:cNvPicPr>
+          <p:nvPr/>
+        </p:nvPicPr>
+        <p:blipFill>
+          <a:blip r:embed="rId5"/>
+          <a:stretch>
+            <a:fillRect/>
+          </a:stretch>
+        </p:blipFill>
+        <p:spPr>
+          <a:xfrm>
+            <a:off x="4583650" y="5740432"/>
+            <a:ext cx="1971675" cy="714375"/>
+          </a:xfrm>
+          <a:prstGeom prst="rect">
+            <a:avLst/>
+          </a:prstGeom>
+        </p:spPr>
+      </p:pic>
+      <p:sp>
+        <p:nvSpPr>
+          <p:cNvPr id="8" name="TextBox 7">
+            <a:extLst>
+              <a:ext uri="{FF2B5EF4-FFF2-40B4-BE49-F238E27FC236}">
+                <a16:creationId xmlns:a16="http://schemas.microsoft.com/office/drawing/2014/main" id="{8F681B54-E0A9-B41E-C037-44DDCF6C775E}"/>
+              </a:ext>
+            </a:extLst>
+          </p:cNvPr>
+          <p:cNvSpPr txBox="1"/>
+          <p:nvPr/>
+        </p:nvSpPr>
+        <p:spPr>
+          <a:xfrm>
+            <a:off x="1253925" y="4311570"/>
+            <a:ext cx="10938075" cy="646331"/>
+          </a:xfrm>
+          <a:prstGeom prst="rect">
+            <a:avLst/>
+          </a:prstGeom>
+          <a:noFill/>
+        </p:spPr>
+        <p:txBody>
+          <a:bodyPr rot="0" spcFirstLastPara="0" vertOverflow="overflow" horzOverflow="overflow" vert="horz" wrap="square" lIns="91440" tIns="45720" rIns="91440" bIns="45720" numCol="1" spcCol="0" rtlCol="0" fromWordArt="0" anchor="t" anchorCtr="0" forceAA="0" compatLnSpc="1">
+            <a:prstTxWarp prst="textNoShape">
+              <a:avLst/>
+            </a:prstTxWarp>
+            <a:spAutoFit/>
+          </a:bodyPr>
+          <a:lstStyle/>
+          <a:p>
+            <a:r>
+              <a:rPr lang="en-US" dirty="0"/>
+              <a:t>As for what I managed, well, I somewhat re-built it, and was able to re-use code, so the same amount of work was done in:</a:t>
+            </a:r>
+          </a:p>
+        </p:txBody>
+      </p:sp>
+      <p:sp>
+        <p:nvSpPr>
+          <p:cNvPr id="9" name="TextBox 8">
+            <a:extLst>
+              <a:ext uri="{FF2B5EF4-FFF2-40B4-BE49-F238E27FC236}">
+                <a16:creationId xmlns:a16="http://schemas.microsoft.com/office/drawing/2014/main" id="{AE3288E0-51B6-7A73-E606-275C7DF688AE}"/>
+              </a:ext>
+            </a:extLst>
+          </p:cNvPr>
+          <p:cNvSpPr txBox="1"/>
+          <p:nvPr/>
+        </p:nvSpPr>
+        <p:spPr>
+          <a:xfrm>
+            <a:off x="1253923" y="5170024"/>
+            <a:ext cx="2305291" cy="369332"/>
+          </a:xfrm>
+          <a:prstGeom prst="rect">
+            <a:avLst/>
+          </a:prstGeom>
+          <a:noFill/>
+        </p:spPr>
+        <p:txBody>
+          <a:bodyPr rot="0" spcFirstLastPara="0" vertOverflow="overflow" horzOverflow="overflow" vert="horz" wrap="square" lIns="91440" tIns="45720" rIns="91440" bIns="45720" numCol="1" spcCol="0" rtlCol="0" fromWordArt="0" anchor="t" anchorCtr="0" forceAA="0" compatLnSpc="1">
+            <a:prstTxWarp prst="textNoShape">
+              <a:avLst/>
+            </a:prstTxWarp>
+            <a:spAutoFit/>
+          </a:bodyPr>
+          <a:lstStyle/>
+          <a:p>
+            <a:r>
+              <a:rPr lang="en-US"/>
+              <a:t>290 commits</a:t>
+            </a:r>
+          </a:p>
+        </p:txBody>
+      </p:sp>
+      <p:sp>
+        <p:nvSpPr>
+          <p:cNvPr id="10" name="TextBox 9">
+            <a:extLst>
+              <a:ext uri="{FF2B5EF4-FFF2-40B4-BE49-F238E27FC236}">
+                <a16:creationId xmlns:a16="http://schemas.microsoft.com/office/drawing/2014/main" id="{BAAB7F55-FE75-F6AC-39D3-27FAEF0FA20C}"/>
+              </a:ext>
+            </a:extLst>
+          </p:cNvPr>
+          <p:cNvSpPr txBox="1"/>
+          <p:nvPr/>
+        </p:nvSpPr>
+        <p:spPr>
+          <a:xfrm>
+            <a:off x="4501034" y="5169564"/>
+            <a:ext cx="2305291" cy="369332"/>
+          </a:xfrm>
+          <a:prstGeom prst="rect">
+            <a:avLst/>
+          </a:prstGeom>
+          <a:noFill/>
+        </p:spPr>
+        <p:txBody>
+          <a:bodyPr rot="0" spcFirstLastPara="0" vertOverflow="overflow" horzOverflow="overflow" vert="horz" wrap="square" lIns="91440" tIns="45720" rIns="91440" bIns="45720" numCol="1" spcCol="0" rtlCol="0" fromWordArt="0" anchor="t" anchorCtr="0" forceAA="0" compatLnSpc="1">
+            <a:prstTxWarp prst="textNoShape">
+              <a:avLst/>
+            </a:prstTxWarp>
+            <a:spAutoFit/>
+          </a:bodyPr>
+          <a:lstStyle/>
+          <a:p>
+            <a:r>
+              <a:rPr lang="en-US"/>
+              <a:t>902 commits</a:t>
+            </a:r>
+          </a:p>
+        </p:txBody>
+      </p:sp>
+      <p:sp>
+        <p:nvSpPr>
+          <p:cNvPr id="11" name="TextBox 10">
+            <a:extLst>
+              <a:ext uri="{FF2B5EF4-FFF2-40B4-BE49-F238E27FC236}">
+                <a16:creationId xmlns:a16="http://schemas.microsoft.com/office/drawing/2014/main" id="{81B330B9-4CC2-04B5-B49D-2D1CCACA779D}"/>
+              </a:ext>
+            </a:extLst>
+          </p:cNvPr>
+          <p:cNvSpPr txBox="1"/>
+          <p:nvPr/>
+        </p:nvSpPr>
+        <p:spPr>
+          <a:xfrm>
+            <a:off x="2732565" y="5160952"/>
+            <a:ext cx="2305291" cy="369332"/>
+          </a:xfrm>
+          <a:prstGeom prst="rect">
+            <a:avLst/>
+          </a:prstGeom>
+          <a:noFill/>
+        </p:spPr>
+        <p:txBody>
+          <a:bodyPr rot="0" spcFirstLastPara="0" vertOverflow="overflow" horzOverflow="overflow" vert="horz" wrap="square" lIns="91440" tIns="45720" rIns="91440" bIns="45720" numCol="1" spcCol="0" rtlCol="0" fromWordArt="0" anchor="t" anchorCtr="0" forceAA="0" compatLnSpc="1">
+            <a:prstTxWarp prst="textNoShape">
+              <a:avLst/>
+            </a:prstTxWarp>
+            <a:spAutoFit/>
+          </a:bodyPr>
+          <a:lstStyle/>
+          <a:p>
+            <a:r>
+              <a:rPr lang="en-US"/>
+              <a:t>As opposed to</a:t>
+            </a:r>
+          </a:p>
+        </p:txBody>
+      </p:sp>
     </p:spTree>
     <p:extLst>
       <p:ext uri="{BB962C8B-B14F-4D97-AF65-F5344CB8AC3E}">
@@ -14771,18 +15050,303 @@
   <p:clrMapOvr>
     <a:masterClrMapping/>
   </p:clrMapOvr>
-  <mc:AlternateContent xmlns:mc="http://schemas.openxmlformats.org/markup-compatibility/2006">
-    <mc:Choice xmlns:p15="http://schemas.microsoft.com/office/powerpoint/2012/main" Requires="p15">
+  <mc:AlternateContent xmlns:mc="http://schemas.openxmlformats.org/markup-compatibility/2006" xmlns:p15="http://schemas.microsoft.com/office/powerpoint/2012/main">
+    <mc:Choice Requires="p15">
       <p:transition xmlns:p14="http://schemas.microsoft.com/office/powerpoint/2010/main" spd="slow" p14:dur="2000">
         <p15:prstTrans prst="fallOver"/>
       </p:transition>
     </mc:Choice>
-    <mc:Fallback>
+    <mc:Fallback xmlns="">
       <p:transition spd="slow">
         <p:fade/>
       </p:transition>
     </mc:Fallback>
   </mc:AlternateContent>
+  <p:timing>
+    <p:tnLst>
+      <p:par>
+        <p:cTn id="1" dur="indefinite" restart="never" nodeType="tmRoot">
+          <p:childTnLst>
+            <p:seq concurrent="1" nextAc="seek">
+              <p:cTn id="2" dur="indefinite" nodeType="mainSeq">
+                <p:childTnLst>
+                  <p:par>
+                    <p:cTn id="3" fill="hold">
+                      <p:stCondLst>
+                        <p:cond delay="indefinite"/>
+                      </p:stCondLst>
+                      <p:childTnLst>
+                        <p:par>
+                          <p:cTn id="4" fill="hold">
+                            <p:stCondLst>
+                              <p:cond delay="0"/>
+                            </p:stCondLst>
+                            <p:childTnLst>
+                              <p:par>
+                                <p:cTn id="5" presetID="2" presetClass="entr" presetSubtype="4" fill="hold" grpId="0" nodeType="clickEffect">
+                                  <p:stCondLst>
+                                    <p:cond delay="0"/>
+                                  </p:stCondLst>
+                                  <p:childTnLst>
+                                    <p:set>
+                                      <p:cBhvr>
+                                        <p:cTn id="6" dur="1" fill="hold">
+                                          <p:stCondLst>
+                                            <p:cond delay="0"/>
+                                          </p:stCondLst>
+                                        </p:cTn>
+                                        <p:tgtEl>
+                                          <p:spTgt spid="3">
+                                            <p:txEl>
+                                              <p:pRg st="0" end="0"/>
+                                            </p:txEl>
+                                          </p:spTgt>
+                                        </p:tgtEl>
+                                        <p:attrNameLst>
+                                          <p:attrName>style.visibility</p:attrName>
+                                        </p:attrNameLst>
+                                      </p:cBhvr>
+                                      <p:to>
+                                        <p:strVal val="visible"/>
+                                      </p:to>
+                                    </p:set>
+                                    <p:anim calcmode="lin" valueType="num">
+                                      <p:cBhvr additive="base">
+                                        <p:cTn id="7" dur="500" fill="hold"/>
+                                        <p:tgtEl>
+                                          <p:spTgt spid="3">
+                                            <p:txEl>
+                                              <p:pRg st="0" end="0"/>
+                                            </p:txEl>
+                                          </p:spTgt>
+                                        </p:tgtEl>
+                                        <p:attrNameLst>
+                                          <p:attrName>ppt_x</p:attrName>
+                                        </p:attrNameLst>
+                                      </p:cBhvr>
+                                      <p:tavLst>
+                                        <p:tav tm="0">
+                                          <p:val>
+                                            <p:strVal val="#ppt_x"/>
+                                          </p:val>
+                                        </p:tav>
+                                        <p:tav tm="100000">
+                                          <p:val>
+                                            <p:strVal val="#ppt_x"/>
+                                          </p:val>
+                                        </p:tav>
+                                      </p:tavLst>
+                                    </p:anim>
+                                    <p:anim calcmode="lin" valueType="num">
+                                      <p:cBhvr additive="base">
+                                        <p:cTn id="8" dur="500" fill="hold"/>
+                                        <p:tgtEl>
+                                          <p:spTgt spid="3">
+                                            <p:txEl>
+                                              <p:pRg st="0" end="0"/>
+                                            </p:txEl>
+                                          </p:spTgt>
+                                        </p:tgtEl>
+                                        <p:attrNameLst>
+                                          <p:attrName>ppt_y</p:attrName>
+                                        </p:attrNameLst>
+                                      </p:cBhvr>
+                                      <p:tavLst>
+                                        <p:tav tm="0">
+                                          <p:val>
+                                            <p:strVal val="1+#ppt_h/2"/>
+                                          </p:val>
+                                        </p:tav>
+                                        <p:tav tm="100000">
+                                          <p:val>
+                                            <p:strVal val="#ppt_y"/>
+                                          </p:val>
+                                        </p:tav>
+                                      </p:tavLst>
+                                    </p:anim>
+                                  </p:childTnLst>
+                                </p:cTn>
+                              </p:par>
+                            </p:childTnLst>
+                          </p:cTn>
+                        </p:par>
+                      </p:childTnLst>
+                    </p:cTn>
+                  </p:par>
+                  <p:par>
+                    <p:cTn id="9" fill="hold">
+                      <p:stCondLst>
+                        <p:cond delay="indefinite"/>
+                      </p:stCondLst>
+                      <p:childTnLst>
+                        <p:par>
+                          <p:cTn id="10" fill="hold">
+                            <p:stCondLst>
+                              <p:cond delay="0"/>
+                            </p:stCondLst>
+                            <p:childTnLst>
+                              <p:par>
+                                <p:cTn id="11" presetID="2" presetClass="entr" presetSubtype="4" fill="hold" grpId="0" nodeType="clickEffect">
+                                  <p:stCondLst>
+                                    <p:cond delay="0"/>
+                                  </p:stCondLst>
+                                  <p:childTnLst>
+                                    <p:set>
+                                      <p:cBhvr>
+                                        <p:cTn id="12" dur="1" fill="hold">
+                                          <p:stCondLst>
+                                            <p:cond delay="0"/>
+                                          </p:stCondLst>
+                                        </p:cTn>
+                                        <p:tgtEl>
+                                          <p:spTgt spid="3">
+                                            <p:txEl>
+                                              <p:pRg st="1" end="1"/>
+                                            </p:txEl>
+                                          </p:spTgt>
+                                        </p:tgtEl>
+                                        <p:attrNameLst>
+                                          <p:attrName>style.visibility</p:attrName>
+                                        </p:attrNameLst>
+                                      </p:cBhvr>
+                                      <p:to>
+                                        <p:strVal val="visible"/>
+                                      </p:to>
+                                    </p:set>
+                                    <p:anim calcmode="lin" valueType="num">
+                                      <p:cBhvr additive="base">
+                                        <p:cTn id="13" dur="500" fill="hold"/>
+                                        <p:tgtEl>
+                                          <p:spTgt spid="3">
+                                            <p:txEl>
+                                              <p:pRg st="1" end="1"/>
+                                            </p:txEl>
+                                          </p:spTgt>
+                                        </p:tgtEl>
+                                        <p:attrNameLst>
+                                          <p:attrName>ppt_x</p:attrName>
+                                        </p:attrNameLst>
+                                      </p:cBhvr>
+                                      <p:tavLst>
+                                        <p:tav tm="0">
+                                          <p:val>
+                                            <p:strVal val="#ppt_x"/>
+                                          </p:val>
+                                        </p:tav>
+                                        <p:tav tm="100000">
+                                          <p:val>
+                                            <p:strVal val="#ppt_x"/>
+                                          </p:val>
+                                        </p:tav>
+                                      </p:tavLst>
+                                    </p:anim>
+                                    <p:anim calcmode="lin" valueType="num">
+                                      <p:cBhvr additive="base">
+                                        <p:cTn id="14" dur="500" fill="hold"/>
+                                        <p:tgtEl>
+                                          <p:spTgt spid="3">
+                                            <p:txEl>
+                                              <p:pRg st="1" end="1"/>
+                                            </p:txEl>
+                                          </p:spTgt>
+                                        </p:tgtEl>
+                                        <p:attrNameLst>
+                                          <p:attrName>ppt_y</p:attrName>
+                                        </p:attrNameLst>
+                                      </p:cBhvr>
+                                      <p:tavLst>
+                                        <p:tav tm="0">
+                                          <p:val>
+                                            <p:strVal val="1+#ppt_h/2"/>
+                                          </p:val>
+                                        </p:tav>
+                                        <p:tav tm="100000">
+                                          <p:val>
+                                            <p:strVal val="#ppt_y"/>
+                                          </p:val>
+                                        </p:tav>
+                                      </p:tavLst>
+                                    </p:anim>
+                                  </p:childTnLst>
+                                </p:cTn>
+                              </p:par>
+                            </p:childTnLst>
+                          </p:cTn>
+                        </p:par>
+                      </p:childTnLst>
+                    </p:cTn>
+                  </p:par>
+                  <p:par>
+                    <p:cTn id="15" fill="hold">
+                      <p:stCondLst>
+                        <p:cond delay="indefinite"/>
+                      </p:stCondLst>
+                      <p:childTnLst>
+                        <p:par>
+                          <p:cTn id="16" fill="hold">
+                            <p:stCondLst>
+                              <p:cond delay="0"/>
+                            </p:stCondLst>
+                            <p:childTnLst>
+                              <p:par>
+                                <p:cTn id="17" presetID="1" presetClass="entr" presetSubtype="0" fill="hold" grpId="0" nodeType="clickEffect">
+                                  <p:stCondLst>
+                                    <p:cond delay="0"/>
+                                  </p:stCondLst>
+                                  <p:childTnLst>
+                                    <p:set>
+                                      <p:cBhvr>
+                                        <p:cTn id="18" dur="1" fill="hold">
+                                          <p:stCondLst>
+                                            <p:cond delay="0"/>
+                                          </p:stCondLst>
+                                        </p:cTn>
+                                        <p:tgtEl>
+                                          <p:spTgt spid="8"/>
+                                        </p:tgtEl>
+                                        <p:attrNameLst>
+                                          <p:attrName>style.visibility</p:attrName>
+                                        </p:attrNameLst>
+                                      </p:cBhvr>
+                                      <p:to>
+                                        <p:strVal val="visible"/>
+                                      </p:to>
+                                    </p:set>
+                                  </p:childTnLst>
+                                </p:cTn>
+                              </p:par>
+                            </p:childTnLst>
+                          </p:cTn>
+                        </p:par>
+                      </p:childTnLst>
+                    </p:cTn>
+                  </p:par>
+                </p:childTnLst>
+              </p:cTn>
+              <p:prevCondLst>
+                <p:cond evt="onPrev" delay="0">
+                  <p:tgtEl>
+                    <p:sldTgt/>
+                  </p:tgtEl>
+                </p:cond>
+              </p:prevCondLst>
+              <p:nextCondLst>
+                <p:cond evt="onNext" delay="0">
+                  <p:tgtEl>
+                    <p:sldTgt/>
+                  </p:tgtEl>
+                </p:cond>
+              </p:nextCondLst>
+            </p:seq>
+          </p:childTnLst>
+        </p:cTn>
+      </p:par>
+    </p:tnLst>
+    <p:bldLst>
+      <p:bldP spid="3" grpId="0" build="p"/>
+      <p:bldP spid="8" grpId="0"/>
+    </p:bldLst>
+  </p:timing>
 </p:sld>
 </file>
 
@@ -14869,13 +15433,13 @@
   <p:clrMapOvr>
     <a:masterClrMapping/>
   </p:clrMapOvr>
-  <mc:AlternateContent xmlns:mc="http://schemas.openxmlformats.org/markup-compatibility/2006">
-    <mc:Choice xmlns:p15="http://schemas.microsoft.com/office/powerpoint/2012/main" Requires="p15">
+  <mc:AlternateContent xmlns:mc="http://schemas.openxmlformats.org/markup-compatibility/2006" xmlns:p15="http://schemas.microsoft.com/office/powerpoint/2012/main">
+    <mc:Choice Requires="p15">
       <p:transition xmlns:p14="http://schemas.microsoft.com/office/powerpoint/2010/main" spd="slow" p14:dur="2000">
         <p15:prstTrans prst="fallOver"/>
       </p:transition>
     </mc:Choice>
-    <mc:Fallback>
+    <mc:Fallback xmlns="">
       <p:transition spd="slow">
         <p:fade/>
       </p:transition>

</xml_diff>